<commit_message>
Projektplanung: neue Projektskizze, PSP und Projektablaufplan, drei Folien in der Präsentation, Anhang
Co-Authored-By: Claude Sonnet 5.5 <noreply@anthropic.com>
Claude-Session: https://claude.ai/code/session_01FgB7we8XF2bWXv4nWDrzG8
</commit_message>
<xml_diff>
--- a/output/praesentation.pptx
+++ b/output/praesentation.pptx
@@ -7,7 +7,9 @@
   <p:sldIdLst>
     <p:sldId id="256" r:id="rId7"/>
     <p:sldId id="257" r:id="rId9"/>
-    <p:sldId id="258" r:id="rId10"/>
+    <p:sldId id="299" r:id="rId51"/>
+    <p:sldId id="300" r:id="rId52"/>
+    <p:sldId id="301" r:id="rId53"/>
     <p:sldId id="259" r:id="rId11"/>
     <p:sldId id="260" r:id="rId12"/>
     <p:sldId id="261" r:id="rId13"/>
@@ -48,6 +50,7 @@
     <p:sldId id="296" r:id="rId48"/>
     <p:sldId id="297" r:id="rId49"/>
     <p:sldId id="298" r:id="rId50"/>
+    <p:sldId id="258" r:id="rId10"/>
   </p:sldIdLst>
   <p:sldSz cx="12191695" cy="6858000" type="screen4x3"/>
   <p:notesSz cx="6858000" cy="9144000"/>
@@ -1211,6 +1214,82 @@
 </p:notes>
 </file>
 
+<file path=ppt/notesSlides/notesSlide19.xml><?xml version="1.0" encoding="utf-8"?>
+<p:notes xmlns:a="http://schemas.openxmlformats.org/drawingml/2006/main" xmlns:p="http://schemas.openxmlformats.org/presentationml/2006/main" xmlns:r="http://schemas.openxmlformats.org/officeDocument/2006/relationships">
+  <p:cSld>
+    <p:spTree>
+      <p:nvGrpSpPr>
+        <p:cNvPr id="1" name=""/>
+        <p:cNvGrpSpPr/>
+        <p:nvPr/>
+      </p:nvGrpSpPr>
+      <p:grpSpPr>
+        <a:xfrm>
+          <a:off x="0" y="0"/>
+          <a:ext cx="0" cy="0"/>
+          <a:chOff x="0" y="0"/>
+          <a:chExt cx="0" cy="0"/>
+        </a:xfrm>
+      </p:grpSpPr>
+      <p:sp>
+        <p:nvSpPr>
+          <p:cNvPr id="2" name="Slide Image Placeholder 1"/>
+          <p:cNvSpPr>
+            <a:spLocks noGrp="1"/>
+          </p:cNvSpPr>
+          <p:nvPr>
+            <p:ph type="sldImg" idx="2"/>
+          </p:nvPr>
+        </p:nvSpPr>
+        <p:spPr/>
+      </p:sp>
+      <p:sp>
+        <p:nvSpPr>
+          <p:cNvPr id="3" name="Notes Placeholder 2"/>
+          <p:cNvSpPr>
+            <a:spLocks noGrp="1"/>
+          </p:cNvSpPr>
+          <p:nvPr>
+            <p:ph type="body" idx="3" sz="quarter"/>
+          </p:nvPr>
+        </p:nvSpPr>
+        <p:spPr/>
+        <p:txBody>
+          <a:bodyPr/>
+          <a:lstStyle/>
+          <a:p>
+            <a:r>
+              <a:t>Yasin: Unsere Projektskizze auf einen Blick: Wir erstellen ein Prüfungsvorbereitungsbooklet für Mitschüler, Laufzeit vom 10. September bis 8. Oktober.</a:t>
+            </a:r>
+          </a:p>
+          <a:p/>
+          <a:p>
+            <a:r>
+              <a:t>Mido: Dazu haben wir zwei SMART-Ziele: erstens Wissen über den Ausbildungsvertrag, zweitens Anwendung im Ausbildungsalltag – messbar am Abschluss-Quiz, beide bis zum 8. Oktober.</a:t>
+            </a:r>
+          </a:p>
+        </p:txBody>
+      </p:sp>
+      <p:sp>
+        <p:nvSpPr>
+          <p:cNvPr id="4" name="Slide Number Placeholder 3"/>
+          <p:cNvSpPr>
+            <a:spLocks noGrp="1"/>
+          </p:cNvSpPr>
+          <p:nvPr>
+            <p:ph type="sldNum" idx="5" sz="quarter"/>
+          </p:nvPr>
+        </p:nvSpPr>
+        <p:spPr/>
+      </p:sp>
+    </p:spTree>
+  </p:cSld>
+  <p:clrMapOvr>
+    <a:masterClrMapping/>
+  </p:clrMapOvr>
+</p:notes>
+</file>
+
 <file path=ppt/notesSlides/notesSlide2.xml><?xml version="1.0" encoding="utf-8"?>
 <p:notes xmlns:a="http://schemas.openxmlformats.org/drawingml/2006/main" xmlns:p="http://schemas.openxmlformats.org/presentationml/2006/main" xmlns:r="http://schemas.openxmlformats.org/officeDocument/2006/relationships">
   <p:cSld>
@@ -1257,6 +1336,158 @@
           <a:p>
             <a:r>
               <a:t>„Unsere Aufgabe: ein Prüfungsvorbereitungsbooklet zu einem Thema der schriftlichen IHK-Abschlussprüfung in Wirtschafts- und Sozialkunde. Wir haben den Ausbildungsvertrag gewählt, weil er Prüfungsstoff ist und sich mit echten Beispielen gut erklären lässt. Bisher gab es dazu kein kompaktes Lernmaterial mit Aufgaben und Lösungen. Unser Ziel: Am 25. November sollt ihr die Regeln zu Beginn und Dauer, Arbeitszeit, Vergütung, Urlaub, Probezeit und Kündigung sicher anwenden können – und das üben wir gleich.“</a:t>
+            </a:r>
+          </a:p>
+        </p:txBody>
+      </p:sp>
+      <p:sp>
+        <p:nvSpPr>
+          <p:cNvPr id="4" name="Slide Number Placeholder 3"/>
+          <p:cNvSpPr>
+            <a:spLocks noGrp="1"/>
+          </p:cNvSpPr>
+          <p:nvPr>
+            <p:ph type="sldNum" idx="5" sz="quarter"/>
+          </p:nvPr>
+        </p:nvSpPr>
+        <p:spPr/>
+      </p:sp>
+    </p:spTree>
+  </p:cSld>
+  <p:clrMapOvr>
+    <a:masterClrMapping/>
+  </p:clrMapOvr>
+</p:notes>
+</file>
+
+<file path=ppt/notesSlides/notesSlide20.xml><?xml version="1.0" encoding="utf-8"?>
+<p:notes xmlns:a="http://schemas.openxmlformats.org/drawingml/2006/main" xmlns:p="http://schemas.openxmlformats.org/presentationml/2006/main" xmlns:r="http://schemas.openxmlformats.org/officeDocument/2006/relationships">
+  <p:cSld>
+    <p:spTree>
+      <p:nvGrpSpPr>
+        <p:cNvPr id="1" name=""/>
+        <p:cNvGrpSpPr/>
+        <p:nvPr/>
+      </p:nvGrpSpPr>
+      <p:grpSpPr>
+        <a:xfrm>
+          <a:off x="0" y="0"/>
+          <a:ext cx="0" cy="0"/>
+          <a:chOff x="0" y="0"/>
+          <a:chExt cx="0" cy="0"/>
+        </a:xfrm>
+      </p:grpSpPr>
+      <p:sp>
+        <p:nvSpPr>
+          <p:cNvPr id="2" name="Slide Image Placeholder 1"/>
+          <p:cNvSpPr>
+            <a:spLocks noGrp="1"/>
+          </p:cNvSpPr>
+          <p:nvPr>
+            <p:ph type="sldImg" idx="2"/>
+          </p:nvPr>
+        </p:nvSpPr>
+        <p:spPr/>
+      </p:sp>
+      <p:sp>
+        <p:nvSpPr>
+          <p:cNvPr id="3" name="Notes Placeholder 2"/>
+          <p:cNvSpPr>
+            <a:spLocks noGrp="1"/>
+          </p:cNvSpPr>
+          <p:nvPr>
+            <p:ph type="body" idx="3" sz="quarter"/>
+          </p:nvPr>
+        </p:nvSpPr>
+        <p:spPr/>
+        <p:txBody>
+          <a:bodyPr/>
+          <a:lstStyle/>
+          <a:p>
+            <a:r>
+              <a:t>Yasin: Unser Projektstrukturplan zeigt alle Aufgaben des Projekts: fünf Teilaufgaben und zwei einzelne Arbeitspakete, zusammen 19 Arbeitspakete.</a:t>
+            </a:r>
+          </a:p>
+          <a:p/>
+          <a:p>
+            <a:r>
+              <a:t>Mido: Jedes Arbeitspaket hat ein klares Ergebnis und eine verantwortliche Person – Yasin, Mido oder wir beide.</a:t>
+            </a:r>
+          </a:p>
+        </p:txBody>
+      </p:sp>
+      <p:sp>
+        <p:nvSpPr>
+          <p:cNvPr id="4" name="Slide Number Placeholder 3"/>
+          <p:cNvSpPr>
+            <a:spLocks noGrp="1"/>
+          </p:cNvSpPr>
+          <p:nvPr>
+            <p:ph type="sldNum" idx="5" sz="quarter"/>
+          </p:nvPr>
+        </p:nvSpPr>
+        <p:spPr/>
+      </p:sp>
+    </p:spTree>
+  </p:cSld>
+  <p:clrMapOvr>
+    <a:masterClrMapping/>
+  </p:clrMapOvr>
+</p:notes>
+</file>
+
+<file path=ppt/notesSlides/notesSlide21.xml><?xml version="1.0" encoding="utf-8"?>
+<p:notes xmlns:a="http://schemas.openxmlformats.org/drawingml/2006/main" xmlns:p="http://schemas.openxmlformats.org/presentationml/2006/main" xmlns:r="http://schemas.openxmlformats.org/officeDocument/2006/relationships">
+  <p:cSld>
+    <p:spTree>
+      <p:nvGrpSpPr>
+        <p:cNvPr id="1" name=""/>
+        <p:cNvGrpSpPr/>
+        <p:nvPr/>
+      </p:nvGrpSpPr>
+      <p:grpSpPr>
+        <a:xfrm>
+          <a:off x="0" y="0"/>
+          <a:ext cx="0" cy="0"/>
+          <a:chOff x="0" y="0"/>
+          <a:chExt cx="0" cy="0"/>
+        </a:xfrm>
+      </p:grpSpPr>
+      <p:sp>
+        <p:nvSpPr>
+          <p:cNvPr id="2" name="Slide Image Placeholder 1"/>
+          <p:cNvSpPr>
+            <a:spLocks noGrp="1"/>
+          </p:cNvSpPr>
+          <p:nvPr>
+            <p:ph type="sldImg" idx="2"/>
+          </p:nvPr>
+        </p:nvSpPr>
+        <p:spPr/>
+      </p:sp>
+      <p:sp>
+        <p:nvSpPr>
+          <p:cNvPr id="3" name="Notes Placeholder 2"/>
+          <p:cNvSpPr>
+            <a:spLocks noGrp="1"/>
+          </p:cNvSpPr>
+          <p:nvPr>
+            <p:ph type="body" idx="3" sz="quarter"/>
+          </p:nvPr>
+        </p:nvSpPr>
+        <p:spPr/>
+        <p:txBody>
+          <a:bodyPr/>
+          <a:lstStyle/>
+          <a:p>
+            <a:r>
+              <a:t>Yasin: Der Projektablaufplan legt für jedes Arbeitspaket Dauer und Zeitraum fest, vom 10. September bis zum 8. Oktober.</a:t>
+            </a:r>
+          </a:p>
+          <a:p/>
+          <a:p>
+            <a:r>
+              <a:t>Mido: Fünf Meilensteine sichern den Plan – der letzte ist die Präsentation am 8. Oktober.</a:t>
             </a:r>
           </a:p>
         </p:txBody>
@@ -30483,6 +30714,1224 @@
 </p:sld>
 </file>
 
+<file path=ppt/slides/slide44.xml><?xml version="1.0" encoding="utf-8"?>
+<p:sld xmlns:a="http://schemas.openxmlformats.org/drawingml/2006/main" xmlns:p="http://schemas.openxmlformats.org/presentationml/2006/main" xmlns:r="http://schemas.openxmlformats.org/officeDocument/2006/relationships">
+  <p:cSld>
+    <p:spTree>
+      <p:nvGrpSpPr>
+        <p:cNvPr id="1" name=""/>
+        <p:cNvGrpSpPr/>
+        <p:nvPr/>
+      </p:nvGrpSpPr>
+      <p:grpSpPr/>
+      <p:sp>
+        <p:nvSpPr>
+          <p:cNvPr id="2" name="Rectangle 1"/>
+          <p:cNvSpPr/>
+          <p:nvPr/>
+        </p:nvSpPr>
+        <p:spPr>
+          <a:xfrm>
+            <a:off x="0" y="0"/>
+            <a:ext cx="320040" cy="6858000"/>
+          </a:xfrm>
+          <a:prstGeom prst="rect">
+            <a:avLst/>
+          </a:prstGeom>
+          <a:solidFill>
+            <a:srgbClr val="F5A800"/>
+          </a:solidFill>
+          <a:ln>
+            <a:noFill/>
+          </a:ln>
+          <a:effectLst/>
+        </p:spPr>
+        <p:style>
+          <a:lnRef idx="1">
+            <a:schemeClr val="accent1"/>
+          </a:lnRef>
+          <a:fillRef idx="3">
+            <a:schemeClr val="accent1"/>
+          </a:fillRef>
+          <a:effectRef idx="2">
+            <a:schemeClr val="accent1"/>
+          </a:effectRef>
+          <a:fontRef idx="minor">
+            <a:schemeClr val="lt1"/>
+          </a:fontRef>
+        </p:style>
+        <p:txBody>
+          <a:bodyPr rtlCol="0" anchor="ctr"/>
+          <a:lstStyle/>
+          <a:p>
+            <a:pPr algn="ctr"/>
+          </a:p>
+        </p:txBody>
+      </p:sp>
+      <p:sp>
+        <p:nvSpPr>
+          <p:cNvPr id="3" name="TextBox 2"/>
+          <p:cNvSpPr txBox="1"/>
+          <p:nvPr/>
+        </p:nvSpPr>
+        <p:spPr>
+          <a:xfrm>
+            <a:off x="640080" y="274320"/>
+            <a:ext cx="10058400" cy="320040"/>
+          </a:xfrm>
+          <a:prstGeom prst="rect">
+            <a:avLst/>
+          </a:prstGeom>
+          <a:noFill/>
+        </p:spPr>
+        <p:txBody>
+          <a:bodyPr wrap="square" anchor="t">
+            <a:spAutoFit/>
+          </a:bodyPr>
+          <a:lstStyle/>
+          <a:p>
+            <a:r>
+              <a:rPr sz="1300" b="1">
+                <a:solidFill>
+                  <a:srgbClr val="B07A00"/>
+                </a:solidFill>
+                <a:latin typeface="Arial"/>
+              </a:rPr>
+              <a:t>AUFGABE, PROBLEM, ZIEL</a:t>
+            </a:r>
+          </a:p>
+        </p:txBody>
+      </p:sp>
+      <p:sp>
+        <p:nvSpPr>
+          <p:cNvPr id="4" name="TextBox 3"/>
+          <p:cNvSpPr txBox="1"/>
+          <p:nvPr/>
+        </p:nvSpPr>
+        <p:spPr>
+          <a:xfrm>
+            <a:off x="640080" y="548640"/>
+            <a:ext cx="10972800" cy="822960"/>
+          </a:xfrm>
+          <a:prstGeom prst="rect">
+            <a:avLst/>
+          </a:prstGeom>
+          <a:noFill/>
+        </p:spPr>
+        <p:txBody>
+          <a:bodyPr wrap="square" anchor="t">
+            <a:spAutoFit/>
+          </a:bodyPr>
+          <a:lstStyle/>
+          <a:p>
+            <a:r>
+              <a:rPr sz="3200" b="1">
+                <a:solidFill>
+                  <a:srgbClr val="14264B"/>
+                </a:solidFill>
+                <a:latin typeface="Arial"/>
+              </a:rPr>
+              <a:t>Projektskizze auf einen Blick</a:t>
+            </a:r>
+          </a:p>
+        </p:txBody>
+      </p:sp>
+      <p:sp>
+        <p:nvSpPr>
+          <p:cNvPr id="5" name="Rectangle 4"/>
+          <p:cNvSpPr/>
+          <p:nvPr/>
+        </p:nvSpPr>
+        <p:spPr>
+          <a:xfrm>
+            <a:off x="640080" y="1508760"/>
+            <a:ext cx="3657600" cy="1600200"/>
+          </a:xfrm>
+          <a:prstGeom prst="rect">
+            <a:avLst/>
+          </a:prstGeom>
+          <a:solidFill>
+            <a:srgbClr val="E8EEF9"/>
+          </a:solidFill>
+          <a:ln>
+            <a:noFill/>
+          </a:ln>
+          <a:effectLst/>
+        </p:spPr>
+        <p:style>
+          <a:lnRef idx="1">
+            <a:schemeClr val="accent1"/>
+          </a:lnRef>
+          <a:fillRef idx="3">
+            <a:schemeClr val="accent1"/>
+          </a:fillRef>
+          <a:effectRef idx="2">
+            <a:schemeClr val="accent1"/>
+          </a:effectRef>
+          <a:fontRef idx="minor">
+            <a:schemeClr val="lt1"/>
+          </a:fontRef>
+        </p:style>
+        <p:txBody>
+          <a:bodyPr rtlCol="0" anchor="ctr"/>
+          <a:lstStyle/>
+          <a:p>
+            <a:pPr algn="ctr"/>
+          </a:p>
+        </p:txBody>
+      </p:sp>
+      <p:sp>
+        <p:nvSpPr>
+          <p:cNvPr id="6" name="Rectangle 5"/>
+          <p:cNvSpPr/>
+          <p:nvPr/>
+        </p:nvSpPr>
+        <p:spPr>
+          <a:xfrm>
+            <a:off x="640080" y="1508760"/>
+            <a:ext cx="91440" cy="1600200"/>
+          </a:xfrm>
+          <a:prstGeom prst="rect">
+            <a:avLst/>
+          </a:prstGeom>
+          <a:solidFill>
+            <a:srgbClr val="22386B"/>
+          </a:solidFill>
+          <a:ln>
+            <a:noFill/>
+          </a:ln>
+          <a:effectLst/>
+        </p:spPr>
+        <p:style>
+          <a:lnRef idx="1">
+            <a:schemeClr val="accent1"/>
+          </a:lnRef>
+          <a:fillRef idx="3">
+            <a:schemeClr val="accent1"/>
+          </a:fillRef>
+          <a:effectRef idx="2">
+            <a:schemeClr val="accent1"/>
+          </a:effectRef>
+          <a:fontRef idx="minor">
+            <a:schemeClr val="lt1"/>
+          </a:fontRef>
+        </p:style>
+        <p:txBody>
+          <a:bodyPr rtlCol="0" anchor="ctr"/>
+          <a:lstStyle/>
+          <a:p>
+            <a:pPr algn="ctr"/>
+          </a:p>
+        </p:txBody>
+      </p:sp>
+      <p:sp>
+        <p:nvSpPr>
+          <p:cNvPr id="7" name="TextBox 6"/>
+          <p:cNvSpPr txBox="1"/>
+          <p:nvPr/>
+        </p:nvSpPr>
+        <p:spPr>
+          <a:xfrm>
+            <a:off x="868680" y="1600200"/>
+            <a:ext cx="3291840" cy="457200"/>
+          </a:xfrm>
+          <a:prstGeom prst="rect">
+            <a:avLst/>
+          </a:prstGeom>
+          <a:noFill/>
+        </p:spPr>
+        <p:txBody>
+          <a:bodyPr wrap="square" anchor="t">
+            <a:spAutoFit/>
+          </a:bodyPr>
+          <a:lstStyle/>
+          <a:p>
+            <a:r>
+              <a:rPr sz="2000" b="1">
+                <a:solidFill>
+                  <a:srgbClr val="14264B"/>
+                </a:solidFill>
+                <a:latin typeface="Arial"/>
+              </a:rPr>
+              <a:t>Ziel</a:t>
+            </a:r>
+          </a:p>
+        </p:txBody>
+      </p:sp>
+      <p:sp>
+        <p:nvSpPr>
+          <p:cNvPr id="8" name="TextBox 7"/>
+          <p:cNvSpPr txBox="1"/>
+          <p:nvPr/>
+        </p:nvSpPr>
+        <p:spPr>
+          <a:xfrm>
+            <a:off x="868680" y="2203704"/>
+            <a:ext cx="3291840" cy="868680"/>
+          </a:xfrm>
+          <a:prstGeom prst="rect">
+            <a:avLst/>
+          </a:prstGeom>
+          <a:noFill/>
+        </p:spPr>
+        <p:txBody>
+          <a:bodyPr wrap="square" anchor="t">
+            <a:spAutoFit/>
+          </a:bodyPr>
+          <a:lstStyle/>
+          <a:p>
+            <a:r>
+              <a:rPr sz="1900" b="0">
+                <a:solidFill>
+                  <a:srgbClr val="1A2238"/>
+                </a:solidFill>
+                <a:latin typeface="Arial"/>
+              </a:rPr>
+              <a:t>Booklet zur Prüfungsvorbereitung mit Prüfungstraining</a:t>
+            </a:r>
+          </a:p>
+        </p:txBody>
+      </p:sp>
+      <p:sp>
+        <p:nvSpPr>
+          <p:cNvPr id="9" name="Rectangle 8"/>
+          <p:cNvSpPr/>
+          <p:nvPr/>
+        </p:nvSpPr>
+        <p:spPr>
+          <a:xfrm>
+            <a:off x="4480560" y="1508760"/>
+            <a:ext cx="3657600" cy="1600200"/>
+          </a:xfrm>
+          <a:prstGeom prst="rect">
+            <a:avLst/>
+          </a:prstGeom>
+          <a:solidFill>
+            <a:srgbClr val="E8EEF9"/>
+          </a:solidFill>
+          <a:ln>
+            <a:noFill/>
+          </a:ln>
+          <a:effectLst/>
+        </p:spPr>
+        <p:style>
+          <a:lnRef idx="1">
+            <a:schemeClr val="accent1"/>
+          </a:lnRef>
+          <a:fillRef idx="3">
+            <a:schemeClr val="accent1"/>
+          </a:fillRef>
+          <a:effectRef idx="2">
+            <a:schemeClr val="accent1"/>
+          </a:effectRef>
+          <a:fontRef idx="minor">
+            <a:schemeClr val="lt1"/>
+          </a:fontRef>
+        </p:style>
+        <p:txBody>
+          <a:bodyPr rtlCol="0" anchor="ctr"/>
+          <a:lstStyle/>
+          <a:p>
+            <a:pPr algn="ctr"/>
+          </a:p>
+        </p:txBody>
+      </p:sp>
+      <p:sp>
+        <p:nvSpPr>
+          <p:cNvPr id="10" name="Rectangle 9"/>
+          <p:cNvSpPr/>
+          <p:nvPr/>
+        </p:nvSpPr>
+        <p:spPr>
+          <a:xfrm>
+            <a:off x="4480560" y="1508760"/>
+            <a:ext cx="91440" cy="1600200"/>
+          </a:xfrm>
+          <a:prstGeom prst="rect">
+            <a:avLst/>
+          </a:prstGeom>
+          <a:solidFill>
+            <a:srgbClr val="22386B"/>
+          </a:solidFill>
+          <a:ln>
+            <a:noFill/>
+          </a:ln>
+          <a:effectLst/>
+        </p:spPr>
+        <p:style>
+          <a:lnRef idx="1">
+            <a:schemeClr val="accent1"/>
+          </a:lnRef>
+          <a:fillRef idx="3">
+            <a:schemeClr val="accent1"/>
+          </a:fillRef>
+          <a:effectRef idx="2">
+            <a:schemeClr val="accent1"/>
+          </a:effectRef>
+          <a:fontRef idx="minor">
+            <a:schemeClr val="lt1"/>
+          </a:fontRef>
+        </p:style>
+        <p:txBody>
+          <a:bodyPr rtlCol="0" anchor="ctr"/>
+          <a:lstStyle/>
+          <a:p>
+            <a:pPr algn="ctr"/>
+          </a:p>
+        </p:txBody>
+      </p:sp>
+      <p:sp>
+        <p:nvSpPr>
+          <p:cNvPr id="11" name="TextBox 10"/>
+          <p:cNvSpPr txBox="1"/>
+          <p:nvPr/>
+        </p:nvSpPr>
+        <p:spPr>
+          <a:xfrm>
+            <a:off x="4709160" y="1600200"/>
+            <a:ext cx="3291840" cy="457200"/>
+          </a:xfrm>
+          <a:prstGeom prst="rect">
+            <a:avLst/>
+          </a:prstGeom>
+          <a:noFill/>
+        </p:spPr>
+        <p:txBody>
+          <a:bodyPr wrap="square" anchor="t">
+            <a:spAutoFit/>
+          </a:bodyPr>
+          <a:lstStyle/>
+          <a:p>
+            <a:r>
+              <a:rPr sz="2000" b="1">
+                <a:solidFill>
+                  <a:srgbClr val="14264B"/>
+                </a:solidFill>
+                <a:latin typeface="Arial"/>
+              </a:rPr>
+              <a:t>Zielgruppe</a:t>
+            </a:r>
+          </a:p>
+        </p:txBody>
+      </p:sp>
+      <p:sp>
+        <p:nvSpPr>
+          <p:cNvPr id="12" name="TextBox 11"/>
+          <p:cNvSpPr txBox="1"/>
+          <p:nvPr/>
+        </p:nvSpPr>
+        <p:spPr>
+          <a:xfrm>
+            <a:off x="4709160" y="2203704"/>
+            <a:ext cx="3291840" cy="868680"/>
+          </a:xfrm>
+          <a:prstGeom prst="rect">
+            <a:avLst/>
+          </a:prstGeom>
+          <a:noFill/>
+        </p:spPr>
+        <p:txBody>
+          <a:bodyPr wrap="square" anchor="t">
+            <a:spAutoFit/>
+          </a:bodyPr>
+          <a:lstStyle/>
+          <a:p>
+            <a:r>
+              <a:rPr sz="1900" b="0">
+                <a:solidFill>
+                  <a:srgbClr val="1A2238"/>
+                </a:solidFill>
+                <a:latin typeface="Arial"/>
+              </a:rPr>
+              <a:t>Mitschüler vor der Abschlussprüfung am 25.11.</a:t>
+            </a:r>
+          </a:p>
+        </p:txBody>
+      </p:sp>
+      <p:sp>
+        <p:nvSpPr>
+          <p:cNvPr id="13" name="Rectangle 12"/>
+          <p:cNvSpPr/>
+          <p:nvPr/>
+        </p:nvSpPr>
+        <p:spPr>
+          <a:xfrm>
+            <a:off x="8321040" y="1508760"/>
+            <a:ext cx="3246120" cy="1600200"/>
+          </a:xfrm>
+          <a:prstGeom prst="rect">
+            <a:avLst/>
+          </a:prstGeom>
+          <a:solidFill>
+            <a:srgbClr val="FFF1CC"/>
+          </a:solidFill>
+          <a:ln>
+            <a:noFill/>
+          </a:ln>
+          <a:effectLst/>
+        </p:spPr>
+        <p:style>
+          <a:lnRef idx="1">
+            <a:schemeClr val="accent1"/>
+          </a:lnRef>
+          <a:fillRef idx="3">
+            <a:schemeClr val="accent1"/>
+          </a:fillRef>
+          <a:effectRef idx="2">
+            <a:schemeClr val="accent1"/>
+          </a:effectRef>
+          <a:fontRef idx="minor">
+            <a:schemeClr val="lt1"/>
+          </a:fontRef>
+        </p:style>
+        <p:txBody>
+          <a:bodyPr rtlCol="0" anchor="ctr"/>
+          <a:lstStyle/>
+          <a:p>
+            <a:pPr algn="ctr"/>
+          </a:p>
+        </p:txBody>
+      </p:sp>
+      <p:sp>
+        <p:nvSpPr>
+          <p:cNvPr id="14" name="Rectangle 13"/>
+          <p:cNvSpPr/>
+          <p:nvPr/>
+        </p:nvSpPr>
+        <p:spPr>
+          <a:xfrm>
+            <a:off x="8321040" y="1508760"/>
+            <a:ext cx="91440" cy="1600200"/>
+          </a:xfrm>
+          <a:prstGeom prst="rect">
+            <a:avLst/>
+          </a:prstGeom>
+          <a:solidFill>
+            <a:srgbClr val="F5A800"/>
+          </a:solidFill>
+          <a:ln>
+            <a:noFill/>
+          </a:ln>
+          <a:effectLst/>
+        </p:spPr>
+        <p:style>
+          <a:lnRef idx="1">
+            <a:schemeClr val="accent1"/>
+          </a:lnRef>
+          <a:fillRef idx="3">
+            <a:schemeClr val="accent1"/>
+          </a:fillRef>
+          <a:effectRef idx="2">
+            <a:schemeClr val="accent1"/>
+          </a:effectRef>
+          <a:fontRef idx="minor">
+            <a:schemeClr val="lt1"/>
+          </a:fontRef>
+        </p:style>
+        <p:txBody>
+          <a:bodyPr rtlCol="0" anchor="ctr"/>
+          <a:lstStyle/>
+          <a:p>
+            <a:pPr algn="ctr"/>
+          </a:p>
+        </p:txBody>
+      </p:sp>
+      <p:sp>
+        <p:nvSpPr>
+          <p:cNvPr id="15" name="TextBox 14"/>
+          <p:cNvSpPr txBox="1"/>
+          <p:nvPr/>
+        </p:nvSpPr>
+        <p:spPr>
+          <a:xfrm>
+            <a:off x="8549640" y="1600200"/>
+            <a:ext cx="2880360" cy="457200"/>
+          </a:xfrm>
+          <a:prstGeom prst="rect">
+            <a:avLst/>
+          </a:prstGeom>
+          <a:noFill/>
+        </p:spPr>
+        <p:txBody>
+          <a:bodyPr wrap="square" anchor="t">
+            <a:spAutoFit/>
+          </a:bodyPr>
+          <a:lstStyle/>
+          <a:p>
+            <a:r>
+              <a:rPr sz="2000" b="1">
+                <a:solidFill>
+                  <a:srgbClr val="14264B"/>
+                </a:solidFill>
+                <a:latin typeface="Arial"/>
+              </a:rPr>
+              <a:t>Laufzeit</a:t>
+            </a:r>
+          </a:p>
+        </p:txBody>
+      </p:sp>
+      <p:sp>
+        <p:nvSpPr>
+          <p:cNvPr id="16" name="TextBox 15"/>
+          <p:cNvSpPr txBox="1"/>
+          <p:nvPr/>
+        </p:nvSpPr>
+        <p:spPr>
+          <a:xfrm>
+            <a:off x="8549640" y="2203704"/>
+            <a:ext cx="2880360" cy="868680"/>
+          </a:xfrm>
+          <a:prstGeom prst="rect">
+            <a:avLst/>
+          </a:prstGeom>
+          <a:noFill/>
+        </p:spPr>
+        <p:txBody>
+          <a:bodyPr wrap="square" anchor="t">
+            <a:spAutoFit/>
+          </a:bodyPr>
+          <a:lstStyle/>
+          <a:p>
+            <a:r>
+              <a:rPr sz="2200" b="0">
+                <a:solidFill>
+                  <a:srgbClr val="1A2238"/>
+                </a:solidFill>
+                <a:latin typeface="Arial"/>
+              </a:rPr>
+              <a:t>10.09. – 08.10.2026</a:t>
+            </a:r>
+          </a:p>
+        </p:txBody>
+      </p:sp>
+      <p:sp>
+        <p:nvSpPr>
+          <p:cNvPr id="17" name="Rectangle 16"/>
+          <p:cNvSpPr/>
+          <p:nvPr/>
+        </p:nvSpPr>
+        <p:spPr>
+          <a:xfrm>
+            <a:off x="640080" y="3337560"/>
+            <a:ext cx="5440680" cy="3108960"/>
+          </a:xfrm>
+          <a:prstGeom prst="rect">
+            <a:avLst/>
+          </a:prstGeom>
+          <a:solidFill>
+            <a:srgbClr val="E8EEF9"/>
+          </a:solidFill>
+          <a:ln>
+            <a:noFill/>
+          </a:ln>
+          <a:effectLst/>
+        </p:spPr>
+        <p:style>
+          <a:lnRef idx="1">
+            <a:schemeClr val="accent1"/>
+          </a:lnRef>
+          <a:fillRef idx="3">
+            <a:schemeClr val="accent1"/>
+          </a:fillRef>
+          <a:effectRef idx="2">
+            <a:schemeClr val="accent1"/>
+          </a:effectRef>
+          <a:fontRef idx="minor">
+            <a:schemeClr val="lt1"/>
+          </a:fontRef>
+        </p:style>
+        <p:txBody>
+          <a:bodyPr rtlCol="0" anchor="ctr"/>
+          <a:lstStyle/>
+          <a:p>
+            <a:pPr algn="ctr"/>
+          </a:p>
+        </p:txBody>
+      </p:sp>
+      <p:sp>
+        <p:nvSpPr>
+          <p:cNvPr id="18" name="Rectangle 17"/>
+          <p:cNvSpPr/>
+          <p:nvPr/>
+        </p:nvSpPr>
+        <p:spPr>
+          <a:xfrm>
+            <a:off x="640080" y="3337560"/>
+            <a:ext cx="91440" cy="3108960"/>
+          </a:xfrm>
+          <a:prstGeom prst="rect">
+            <a:avLst/>
+          </a:prstGeom>
+          <a:solidFill>
+            <a:srgbClr val="22386B"/>
+          </a:solidFill>
+          <a:ln>
+            <a:noFill/>
+          </a:ln>
+          <a:effectLst/>
+        </p:spPr>
+        <p:style>
+          <a:lnRef idx="1">
+            <a:schemeClr val="accent1"/>
+          </a:lnRef>
+          <a:fillRef idx="3">
+            <a:schemeClr val="accent1"/>
+          </a:fillRef>
+          <a:effectRef idx="2">
+            <a:schemeClr val="accent1"/>
+          </a:effectRef>
+          <a:fontRef idx="minor">
+            <a:schemeClr val="lt1"/>
+          </a:fontRef>
+        </p:style>
+        <p:txBody>
+          <a:bodyPr rtlCol="0" anchor="ctr"/>
+          <a:lstStyle/>
+          <a:p>
+            <a:pPr algn="ctr"/>
+          </a:p>
+        </p:txBody>
+      </p:sp>
+      <p:sp>
+        <p:nvSpPr>
+          <p:cNvPr id="19" name="TextBox 18"/>
+          <p:cNvSpPr txBox="1"/>
+          <p:nvPr/>
+        </p:nvSpPr>
+        <p:spPr>
+          <a:xfrm>
+            <a:off x="868680" y="3429000"/>
+            <a:ext cx="5074920" cy="457200"/>
+          </a:xfrm>
+          <a:prstGeom prst="rect">
+            <a:avLst/>
+          </a:prstGeom>
+          <a:noFill/>
+        </p:spPr>
+        <p:txBody>
+          <a:bodyPr wrap="square" anchor="t">
+            <a:spAutoFit/>
+          </a:bodyPr>
+          <a:lstStyle/>
+          <a:p>
+            <a:r>
+              <a:rPr sz="2200" b="1">
+                <a:solidFill>
+                  <a:srgbClr val="14264B"/>
+                </a:solidFill>
+                <a:latin typeface="Arial"/>
+              </a:rPr>
+              <a:t>SMART-Ziel 1 · Wissen</a:t>
+            </a:r>
+          </a:p>
+        </p:txBody>
+      </p:sp>
+      <p:sp>
+        <p:nvSpPr>
+          <p:cNvPr id="20" name="TextBox 19"/>
+          <p:cNvSpPr txBox="1"/>
+          <p:nvPr/>
+        </p:nvSpPr>
+        <p:spPr>
+          <a:xfrm>
+            <a:off x="868680" y="4080052"/>
+            <a:ext cx="5074920" cy="2377439"/>
+          </a:xfrm>
+          <a:prstGeom prst="rect">
+            <a:avLst/>
+          </a:prstGeom>
+          <a:noFill/>
+        </p:spPr>
+        <p:txBody>
+          <a:bodyPr wrap="square" anchor="t">
+            <a:spAutoFit/>
+          </a:bodyPr>
+          <a:lstStyle/>
+          <a:p>
+            <a:r>
+              <a:rPr sz="2100" b="0">
+                <a:solidFill>
+                  <a:srgbClr val="1A2238"/>
+                </a:solidFill>
+                <a:latin typeface="Arial"/>
+              </a:rPr>
+              <a:t>Bis 08.10. die wichtigsten Regelungen aus BBiG und Ausbildungsvertrag kennen und für alle sechs Prüfungspunkte ein Beispiel erklären können.</a:t>
+            </a:r>
+          </a:p>
+        </p:txBody>
+      </p:sp>
+      <p:sp>
+        <p:nvSpPr>
+          <p:cNvPr id="21" name="Rectangle 20"/>
+          <p:cNvSpPr/>
+          <p:nvPr/>
+        </p:nvSpPr>
+        <p:spPr>
+          <a:xfrm>
+            <a:off x="6263640" y="3337560"/>
+            <a:ext cx="5303520" cy="3108960"/>
+          </a:xfrm>
+          <a:prstGeom prst="rect">
+            <a:avLst/>
+          </a:prstGeom>
+          <a:solidFill>
+            <a:srgbClr val="FFF1CC"/>
+          </a:solidFill>
+          <a:ln>
+            <a:noFill/>
+          </a:ln>
+          <a:effectLst/>
+        </p:spPr>
+        <p:style>
+          <a:lnRef idx="1">
+            <a:schemeClr val="accent1"/>
+          </a:lnRef>
+          <a:fillRef idx="3">
+            <a:schemeClr val="accent1"/>
+          </a:fillRef>
+          <a:effectRef idx="2">
+            <a:schemeClr val="accent1"/>
+          </a:effectRef>
+          <a:fontRef idx="minor">
+            <a:schemeClr val="lt1"/>
+          </a:fontRef>
+        </p:style>
+        <p:txBody>
+          <a:bodyPr rtlCol="0" anchor="ctr"/>
+          <a:lstStyle/>
+          <a:p>
+            <a:pPr algn="ctr"/>
+          </a:p>
+        </p:txBody>
+      </p:sp>
+      <p:sp>
+        <p:nvSpPr>
+          <p:cNvPr id="22" name="Rectangle 21"/>
+          <p:cNvSpPr/>
+          <p:nvPr/>
+        </p:nvSpPr>
+        <p:spPr>
+          <a:xfrm>
+            <a:off x="6263640" y="3337560"/>
+            <a:ext cx="91440" cy="3108960"/>
+          </a:xfrm>
+          <a:prstGeom prst="rect">
+            <a:avLst/>
+          </a:prstGeom>
+          <a:solidFill>
+            <a:srgbClr val="F5A800"/>
+          </a:solidFill>
+          <a:ln>
+            <a:noFill/>
+          </a:ln>
+          <a:effectLst/>
+        </p:spPr>
+        <p:style>
+          <a:lnRef idx="1">
+            <a:schemeClr val="accent1"/>
+          </a:lnRef>
+          <a:fillRef idx="3">
+            <a:schemeClr val="accent1"/>
+          </a:fillRef>
+          <a:effectRef idx="2">
+            <a:schemeClr val="accent1"/>
+          </a:effectRef>
+          <a:fontRef idx="minor">
+            <a:schemeClr val="lt1"/>
+          </a:fontRef>
+        </p:style>
+        <p:txBody>
+          <a:bodyPr rtlCol="0" anchor="ctr"/>
+          <a:lstStyle/>
+          <a:p>
+            <a:pPr algn="ctr"/>
+          </a:p>
+        </p:txBody>
+      </p:sp>
+      <p:sp>
+        <p:nvSpPr>
+          <p:cNvPr id="23" name="TextBox 22"/>
+          <p:cNvSpPr txBox="1"/>
+          <p:nvPr/>
+        </p:nvSpPr>
+        <p:spPr>
+          <a:xfrm>
+            <a:off x="6492240" y="3429000"/>
+            <a:ext cx="4937759" cy="457200"/>
+          </a:xfrm>
+          <a:prstGeom prst="rect">
+            <a:avLst/>
+          </a:prstGeom>
+          <a:noFill/>
+        </p:spPr>
+        <p:txBody>
+          <a:bodyPr wrap="square" anchor="t">
+            <a:spAutoFit/>
+          </a:bodyPr>
+          <a:lstStyle/>
+          <a:p>
+            <a:r>
+              <a:rPr sz="2200" b="1">
+                <a:solidFill>
+                  <a:srgbClr val="14264B"/>
+                </a:solidFill>
+                <a:latin typeface="Arial"/>
+              </a:rPr>
+              <a:t>SMART-Ziel 2 · Anwendung</a:t>
+            </a:r>
+          </a:p>
+        </p:txBody>
+      </p:sp>
+      <p:sp>
+        <p:nvSpPr>
+          <p:cNvPr id="24" name="TextBox 23"/>
+          <p:cNvSpPr txBox="1"/>
+          <p:nvPr/>
+        </p:nvSpPr>
+        <p:spPr>
+          <a:xfrm>
+            <a:off x="6492240" y="4080052"/>
+            <a:ext cx="4937759" cy="2377439"/>
+          </a:xfrm>
+          <a:prstGeom prst="rect">
+            <a:avLst/>
+          </a:prstGeom>
+          <a:noFill/>
+        </p:spPr>
+        <p:txBody>
+          <a:bodyPr wrap="square" anchor="t">
+            <a:spAutoFit/>
+          </a:bodyPr>
+          <a:lstStyle/>
+          <a:p>
+            <a:r>
+              <a:rPr sz="2100" b="0">
+                <a:solidFill>
+                  <a:srgbClr val="1A2238"/>
+                </a:solidFill>
+                <a:latin typeface="Arial"/>
+              </a:rPr>
+              <a:t>Bis 08.10. ordnen Mitschüler mit dem Booklet typische Situationen der passenden Regelung zu: im Abschluss-Quiz im Schnitt mindestens 4 von 5 richtig.</a:t>
+            </a:r>
+          </a:p>
+        </p:txBody>
+      </p:sp>
+    </p:spTree>
+  </p:cSld>
+  <p:clrMapOvr>
+    <a:masterClrMapping/>
+  </p:clrMapOvr>
+</p:sld>
+</file>
+
+<file path=ppt/slides/slide45.xml><?xml version="1.0" encoding="utf-8"?>
+<p:sld xmlns:a="http://schemas.openxmlformats.org/drawingml/2006/main" xmlns:p="http://schemas.openxmlformats.org/presentationml/2006/main" xmlns:r="http://schemas.openxmlformats.org/officeDocument/2006/relationships">
+  <p:cSld>
+    <p:spTree>
+      <p:nvGrpSpPr>
+        <p:cNvPr id="1" name=""/>
+        <p:cNvGrpSpPr/>
+        <p:nvPr/>
+      </p:nvGrpSpPr>
+      <p:grpSpPr/>
+      <p:sp>
+        <p:nvSpPr>
+          <p:cNvPr id="2" name="Rectangle 1"/>
+          <p:cNvSpPr/>
+          <p:nvPr/>
+        </p:nvSpPr>
+        <p:spPr>
+          <a:xfrm>
+            <a:off x="0" y="0"/>
+            <a:ext cx="320040" cy="6858000"/>
+          </a:xfrm>
+          <a:prstGeom prst="rect">
+            <a:avLst/>
+          </a:prstGeom>
+          <a:solidFill>
+            <a:srgbClr val="F5A800"/>
+          </a:solidFill>
+          <a:ln>
+            <a:noFill/>
+          </a:ln>
+          <a:effectLst/>
+        </p:spPr>
+        <p:style>
+          <a:lnRef idx="1">
+            <a:schemeClr val="accent1"/>
+          </a:lnRef>
+          <a:fillRef idx="3">
+            <a:schemeClr val="accent1"/>
+          </a:fillRef>
+          <a:effectRef idx="2">
+            <a:schemeClr val="accent1"/>
+          </a:effectRef>
+          <a:fontRef idx="minor">
+            <a:schemeClr val="lt1"/>
+          </a:fontRef>
+        </p:style>
+        <p:txBody>
+          <a:bodyPr rtlCol="0" anchor="ctr"/>
+          <a:lstStyle/>
+          <a:p>
+            <a:pPr algn="ctr"/>
+          </a:p>
+        </p:txBody>
+      </p:sp>
+      <p:sp>
+        <p:nvSpPr>
+          <p:cNvPr id="3" name="TextBox 2"/>
+          <p:cNvSpPr txBox="1"/>
+          <p:nvPr/>
+        </p:nvSpPr>
+        <p:spPr>
+          <a:xfrm>
+            <a:off x="640080" y="274320"/>
+            <a:ext cx="10058400" cy="320040"/>
+          </a:xfrm>
+          <a:prstGeom prst="rect">
+            <a:avLst/>
+          </a:prstGeom>
+          <a:noFill/>
+        </p:spPr>
+        <p:txBody>
+          <a:bodyPr wrap="square" anchor="t">
+            <a:spAutoFit/>
+          </a:bodyPr>
+          <a:lstStyle/>
+          <a:p>
+            <a:r>
+              <a:rPr sz="1300" b="1">
+                <a:solidFill>
+                  <a:srgbClr val="B07A00"/>
+                </a:solidFill>
+                <a:latin typeface="Arial"/>
+              </a:rPr>
+              <a:t>DURCHFÜHRUNG</a:t>
+            </a:r>
+          </a:p>
+        </p:txBody>
+      </p:sp>
+      <p:sp>
+        <p:nvSpPr>
+          <p:cNvPr id="4" name="TextBox 3"/>
+          <p:cNvSpPr txBox="1"/>
+          <p:nvPr/>
+        </p:nvSpPr>
+        <p:spPr>
+          <a:xfrm>
+            <a:off x="640080" y="548640"/>
+            <a:ext cx="10972800" cy="822960"/>
+          </a:xfrm>
+          <a:prstGeom prst="rect">
+            <a:avLst/>
+          </a:prstGeom>
+          <a:noFill/>
+        </p:spPr>
+        <p:txBody>
+          <a:bodyPr wrap="square" anchor="t">
+            <a:spAutoFit/>
+          </a:bodyPr>
+          <a:lstStyle/>
+          <a:p>
+            <a:r>
+              <a:rPr sz="3200" b="1">
+                <a:solidFill>
+                  <a:srgbClr val="14264B"/>
+                </a:solidFill>
+                <a:latin typeface="Arial"/>
+              </a:rPr>
+              <a:t>Projektstrukturplan</a:t>
+            </a:r>
+          </a:p>
+        </p:txBody>
+      </p:sp>
+      <p:pic>
+        <p:nvPicPr>
+          <p:cNvPr id="5" name="Picture 4" descr="psp_folie.png"/>
+          <p:cNvPicPr>
+            <a:picLocks noChangeAspect="1"/>
+          </p:cNvPicPr>
+          <p:nvPr/>
+        </p:nvPicPr>
+        <p:blipFill>
+          <a:blip r:embed="rId3"/>
+          <a:stretch>
+            <a:fillRect/>
+          </a:stretch>
+        </p:blipFill>
+        <p:spPr>
+          <a:xfrm>
+            <a:off x="685800" y="1325880"/>
+            <a:ext cx="11064240" cy="5268686"/>
+          </a:xfrm>
+          <a:prstGeom prst="rect">
+            <a:avLst/>
+          </a:prstGeom>
+        </p:spPr>
+      </p:pic>
+    </p:spTree>
+  </p:cSld>
+  <p:clrMapOvr>
+    <a:masterClrMapping/>
+  </p:clrMapOvr>
+</p:sld>
+</file>
+
+<file path=ppt/slides/slide46.xml><?xml version="1.0" encoding="utf-8"?>
+<p:sld xmlns:a="http://schemas.openxmlformats.org/drawingml/2006/main" xmlns:p="http://schemas.openxmlformats.org/presentationml/2006/main" xmlns:r="http://schemas.openxmlformats.org/officeDocument/2006/relationships">
+  <p:cSld>
+    <p:spTree>
+      <p:nvGrpSpPr>
+        <p:cNvPr id="1" name=""/>
+        <p:cNvGrpSpPr/>
+        <p:nvPr/>
+      </p:nvGrpSpPr>
+      <p:grpSpPr/>
+      <p:sp>
+        <p:nvSpPr>
+          <p:cNvPr id="2" name="Rectangle 1"/>
+          <p:cNvSpPr/>
+          <p:nvPr/>
+        </p:nvSpPr>
+        <p:spPr>
+          <a:xfrm>
+            <a:off x="0" y="0"/>
+            <a:ext cx="320040" cy="6858000"/>
+          </a:xfrm>
+          <a:prstGeom prst="rect">
+            <a:avLst/>
+          </a:prstGeom>
+          <a:solidFill>
+            <a:srgbClr val="F5A800"/>
+          </a:solidFill>
+          <a:ln>
+            <a:noFill/>
+          </a:ln>
+          <a:effectLst/>
+        </p:spPr>
+        <p:style>
+          <a:lnRef idx="1">
+            <a:schemeClr val="accent1"/>
+          </a:lnRef>
+          <a:fillRef idx="3">
+            <a:schemeClr val="accent1"/>
+          </a:fillRef>
+          <a:effectRef idx="2">
+            <a:schemeClr val="accent1"/>
+          </a:effectRef>
+          <a:fontRef idx="minor">
+            <a:schemeClr val="lt1"/>
+          </a:fontRef>
+        </p:style>
+        <p:txBody>
+          <a:bodyPr rtlCol="0" anchor="ctr"/>
+          <a:lstStyle/>
+          <a:p>
+            <a:pPr algn="ctr"/>
+          </a:p>
+        </p:txBody>
+      </p:sp>
+      <p:sp>
+        <p:nvSpPr>
+          <p:cNvPr id="3" name="TextBox 2"/>
+          <p:cNvSpPr txBox="1"/>
+          <p:nvPr/>
+        </p:nvSpPr>
+        <p:spPr>
+          <a:xfrm>
+            <a:off x="640080" y="274320"/>
+            <a:ext cx="10058400" cy="320040"/>
+          </a:xfrm>
+          <a:prstGeom prst="rect">
+            <a:avLst/>
+          </a:prstGeom>
+          <a:noFill/>
+        </p:spPr>
+        <p:txBody>
+          <a:bodyPr wrap="square" anchor="t">
+            <a:spAutoFit/>
+          </a:bodyPr>
+          <a:lstStyle/>
+          <a:p>
+            <a:r>
+              <a:rPr sz="1300" b="1">
+                <a:solidFill>
+                  <a:srgbClr val="B07A00"/>
+                </a:solidFill>
+                <a:latin typeface="Arial"/>
+              </a:rPr>
+              <a:t>DURCHFÜHRUNG</a:t>
+            </a:r>
+          </a:p>
+        </p:txBody>
+      </p:sp>
+      <p:sp>
+        <p:nvSpPr>
+          <p:cNvPr id="4" name="TextBox 3"/>
+          <p:cNvSpPr txBox="1"/>
+          <p:nvPr/>
+        </p:nvSpPr>
+        <p:spPr>
+          <a:xfrm>
+            <a:off x="640080" y="548640"/>
+            <a:ext cx="10972800" cy="822960"/>
+          </a:xfrm>
+          <a:prstGeom prst="rect">
+            <a:avLst/>
+          </a:prstGeom>
+          <a:noFill/>
+        </p:spPr>
+        <p:txBody>
+          <a:bodyPr wrap="square" anchor="t">
+            <a:spAutoFit/>
+          </a:bodyPr>
+          <a:lstStyle/>
+          <a:p>
+            <a:r>
+              <a:rPr sz="3200" b="1">
+                <a:solidFill>
+                  <a:srgbClr val="14264B"/>
+                </a:solidFill>
+                <a:latin typeface="Arial"/>
+              </a:rPr>
+              <a:t>Projektablaufplan (Soll)</a:t>
+            </a:r>
+          </a:p>
+        </p:txBody>
+      </p:sp>
+      <p:pic>
+        <p:nvPicPr>
+          <p:cNvPr id="5" name="Picture 4" descr="gantt_folie.png"/>
+          <p:cNvPicPr>
+            <a:picLocks noChangeAspect="1"/>
+          </p:cNvPicPr>
+          <p:nvPr/>
+        </p:nvPicPr>
+        <p:blipFill>
+          <a:blip r:embed="rId3"/>
+          <a:stretch>
+            <a:fillRect/>
+          </a:stretch>
+        </p:blipFill>
+        <p:spPr>
+          <a:xfrm>
+            <a:off x="685800" y="1325880"/>
+            <a:ext cx="11064240" cy="5268686"/>
+          </a:xfrm>
+          <a:prstGeom prst="rect">
+            <a:avLst/>
+          </a:prstGeom>
+        </p:spPr>
+      </p:pic>
+    </p:spTree>
+  </p:cSld>
+  <p:clrMapOvr>
+    <a:masterClrMapping/>
+  </p:clrMapOvr>
+</p:sld>
+</file>
+
 <file path=ppt/slides/slide5.xml><?xml version="1.0" encoding="utf-8"?>
 <p:sld xmlns:a="http://schemas.openxmlformats.org/drawingml/2006/main" xmlns:p="http://schemas.openxmlformats.org/presentationml/2006/main" xmlns:r="http://schemas.openxmlformats.org/officeDocument/2006/relationships">
   <p:cSld>

</xml_diff>